<commit_message>
fix(template): Section title top-anchor + Quote accent bar for 2 lines
Section layout:
- Changed title placeholder anchor from bottom to top
- Same position and size — text now grows downward instead of upward
- Prevents long section titles from clipping into the header divider

Quote layout:
- Resized title placeholder for ~2 lines of quote text (h=1.0in)
- Accent bar covers title + subtitle area (y=3.3in, h=1.8in)
- Subtitle repositioned to y=4.6in

Updated both clean_slides/example-template/ and examples/custom-template/.
</commit_message>
<xml_diff>
--- a/clean_slides/example-template/example-template.pptx
+++ b/clean_slides/example-template/example-template.pptx
@@ -2311,12 +2311,12 @@
         </p:nvSpPr>
         <p:spPr>
           <a:xfrm>
-            <a:off x="554736" y="4580470"/>
-            <a:ext cx="11082528" cy="677108"/>
+            <a:off x="554736" y="4581144"/>
+            <a:ext cx="11082528" cy="676656"/>
           </a:xfrm>
         </p:spPr>
         <p:txBody>
-          <a:bodyPr anchor="b">
+          <a:bodyPr anchor="t">
             <a:noAutofit/>
           </a:bodyPr>
           <a:lstStyle>
@@ -2692,8 +2692,8 @@
         </p:nvSpPr>
         <p:spPr>
           <a:xfrm>
-            <a:off x="1188720" y="3474720"/>
-            <a:ext cx="36576" cy="1188720"/>
+            <a:off x="1188720" y="3017520"/>
+            <a:ext cx="36576" cy="1645920"/>
           </a:xfrm>
           <a:prstGeom prst="rect">
             <a:avLst/>
@@ -2727,8 +2727,8 @@
         </p:nvSpPr>
         <p:spPr>
           <a:xfrm>
-            <a:off x="1505712" y="3592841"/>
-            <a:ext cx="9180576" cy="486608"/>
+            <a:off x="1505712" y="3200400"/>
+            <a:ext cx="9180576" cy="914400"/>
           </a:xfrm>
           <a:prstGeom prst="rect">
             <a:avLst/>
@@ -2775,7 +2775,7 @@
         </p:nvSpPr>
         <p:spPr>
           <a:xfrm>
-            <a:off x="1505712" y="4284633"/>
+            <a:off x="1505712" y="4206240"/>
             <a:ext cx="9180576" cy="276999"/>
           </a:xfrm>
           <a:prstGeom prst="rect">

</xml_diff>